<commit_message>
test version with type selector
</commit_message>
<xml_diff>
--- a/test_versions/ggg.pptx
+++ b/test_versions/ggg.pptx
@@ -3088,44 +3088,6 @@
         <p:nvPr/>
       </p:nvGrpSpPr>
       <p:grpSpPr/>
-      <p:sp>
-        <p:nvSpPr>
-          <p:cNvPr id="2" name="Title 1"/>
-          <p:cNvSpPr>
-            <a:spLocks noGrp="1"/>
-          </p:cNvSpPr>
-          <p:nvPr>
-            <p:ph type="ctrTitle"/>
-          </p:nvPr>
-        </p:nvSpPr>
-        <p:spPr/>
-        <p:txBody>
-          <a:bodyPr/>
-          <a:lstStyle/>
-          <a:p>
-            <a:r>
-              <a:t>Текст</a:t>
-            </a:r>
-          </a:p>
-        </p:txBody>
-      </p:sp>
-      <p:sp>
-        <p:nvSpPr>
-          <p:cNvPr id="3" name="Subtitle 2"/>
-          <p:cNvSpPr>
-            <a:spLocks noGrp="1"/>
-          </p:cNvSpPr>
-          <p:nvPr>
-            <p:ph type="subTitle" idx="1"/>
-          </p:nvPr>
-        </p:nvSpPr>
-        <p:spPr/>
-        <p:txBody>
-          <a:bodyPr/>
-          <a:lstStyle/>
-          <a:p/>
-        </p:txBody>
-      </p:sp>
     </p:spTree>
   </p:cSld>
   <p:clrMapOvr>

</xml_diff>